<commit_message>
docs: part2 소제목 삭제
</commit_message>
<xml_diff>
--- a/presentation/1001_16-17_Winternitz-Merkle-LMS.pptx
+++ b/presentation/1001_16-17_Winternitz-Merkle-LMS.pptx
@@ -237,7 +237,7 @@
           <a:p>
             <a:fld id="{B52B40C2-3351-40A2-B46D-4B4F877A79B2}" type="datetimeFigureOut">
               <a:rPr lang="ko-KR" altLang="en-US" smtClean="0"/>
-              <a:t>2026-09-30</a:t>
+              <a:t>2026-10-01</a:t>
             </a:fld>
             <a:endParaRPr lang="ko-KR" altLang="en-US" dirty="0"/>
           </a:p>
@@ -3273,7 +3273,7 @@
             <a:fld id="{2ADF637E-82D6-4563-BCF0-C9101F2B5148}" type="datetime1">
               <a:rPr lang="ko-KR" altLang="en-US" smtClean="0"/>
               <a:pPr/>
-              <a:t>2026-09-30</a:t>
+              <a:t>2026-10-01</a:t>
             </a:fld>
             <a:endParaRPr lang="ko-KR" altLang="en-US" dirty="0"/>
           </a:p>
@@ -3488,7 +3488,7 @@
           <a:p>
             <a:fld id="{C9178607-39E6-4CB2-B3CB-AB428B3B6195}" type="datetime1">
               <a:rPr lang="ko-KR" altLang="en-US" smtClean="0"/>
-              <a:t>2026-09-30</a:t>
+              <a:t>2026-10-01</a:t>
             </a:fld>
             <a:endParaRPr lang="ko-KR" altLang="en-US" dirty="0"/>
           </a:p>
@@ -3696,7 +3696,7 @@
           <a:p>
             <a:fld id="{F578A2F2-325F-46A6-8956-F2A49A35BAF8}" type="datetime1">
               <a:rPr lang="ko-KR" altLang="en-US" smtClean="0"/>
-              <a:t>2026-09-30</a:t>
+              <a:t>2026-10-01</a:t>
             </a:fld>
             <a:endParaRPr lang="ko-KR" altLang="en-US" dirty="0"/>
           </a:p>
@@ -3948,7 +3948,7 @@
             <a:fld id="{D58CD677-7AD2-4A27-94BD-C65458D22428}" type="datetime1">
               <a:rPr lang="ko-KR" altLang="en-US" smtClean="0"/>
               <a:pPr/>
-              <a:t>2026-09-30</a:t>
+              <a:t>2026-10-01</a:t>
             </a:fld>
             <a:endParaRPr lang="ko-KR" altLang="en-US" dirty="0"/>
           </a:p>
@@ -6542,7 +6542,7 @@
           <a:p>
             <a:fld id="{2BEF52EC-B397-4D0A-AE91-E0D6840C85A1}" type="datetime1">
               <a:rPr lang="ko-KR" altLang="en-US" smtClean="0"/>
-              <a:t>2026-09-30</a:t>
+              <a:t>2026-10-01</a:t>
             </a:fld>
             <a:endParaRPr lang="ko-KR" altLang="en-US" dirty="0"/>
           </a:p>
@@ -6823,7 +6823,7 @@
           <a:p>
             <a:fld id="{32DD6007-6A42-4C9B-B218-6A32B3A38C67}" type="datetime1">
               <a:rPr lang="ko-KR" altLang="en-US" smtClean="0"/>
-              <a:t>2026-09-30</a:t>
+              <a:t>2026-10-01</a:t>
             </a:fld>
             <a:endParaRPr lang="ko-KR" altLang="en-US" dirty="0"/>
           </a:p>
@@ -7235,7 +7235,7 @@
           <a:p>
             <a:fld id="{F66658DF-8B5F-4351-A42C-BF3495DE7ABE}" type="datetime1">
               <a:rPr lang="ko-KR" altLang="en-US" smtClean="0"/>
-              <a:t>2026-09-30</a:t>
+              <a:t>2026-10-01</a:t>
             </a:fld>
             <a:endParaRPr lang="ko-KR" altLang="en-US" dirty="0"/>
           </a:p>
@@ -7376,7 +7376,7 @@
           <a:p>
             <a:fld id="{74359C48-8150-4FAB-8BEF-6AD61CFC9BBE}" type="datetime1">
               <a:rPr lang="ko-KR" altLang="en-US" smtClean="0"/>
-              <a:t>2026-09-30</a:t>
+              <a:t>2026-10-01</a:t>
             </a:fld>
             <a:endParaRPr lang="ko-KR" altLang="en-US" dirty="0"/>
           </a:p>
@@ -7489,7 +7489,7 @@
           <a:p>
             <a:fld id="{2D41DBCF-1091-470D-AC72-5CF3D00280AC}" type="datetime1">
               <a:rPr lang="ko-KR" altLang="en-US" smtClean="0"/>
-              <a:t>2026-09-30</a:t>
+              <a:t>2026-10-01</a:t>
             </a:fld>
             <a:endParaRPr lang="ko-KR" altLang="en-US" dirty="0"/>
           </a:p>
@@ -7800,7 +7800,7 @@
           <a:p>
             <a:fld id="{4024AE7C-57FB-4DBB-B90C-59145D637BF6}" type="datetime1">
               <a:rPr lang="ko-KR" altLang="en-US" smtClean="0"/>
-              <a:t>2026-09-30</a:t>
+              <a:t>2026-10-01</a:t>
             </a:fld>
             <a:endParaRPr lang="ko-KR" altLang="en-US" dirty="0"/>
           </a:p>
@@ -8088,7 +8088,7 @@
           <a:p>
             <a:fld id="{17D92253-43A0-46E3-918E-3929407A8C01}" type="datetime1">
               <a:rPr lang="ko-KR" altLang="en-US" smtClean="0"/>
-              <a:t>2026-09-30</a:t>
+              <a:t>2026-10-01</a:t>
             </a:fld>
             <a:endParaRPr lang="ko-KR" altLang="en-US" dirty="0"/>
           </a:p>
@@ -9149,7 +9149,7 @@
           <a:p>
             <a:fld id="{75D61A29-800E-482A-B0FD-5A04401ECD92}" type="datetime1">
               <a:rPr lang="ko-KR" altLang="en-US" smtClean="0"/>
-              <a:t>2026-09-30</a:t>
+              <a:t>2026-10-01</a:t>
             </a:fld>
             <a:endParaRPr lang="ko-KR" altLang="en-US" dirty="0"/>
           </a:p>
@@ -9710,8 +9710,8 @@
           </a:p>
         </p:txBody>
       </p:sp>
-      <mc:AlternateContent xmlns:mc="http://schemas.openxmlformats.org/markup-compatibility/2006">
-        <mc:Choice xmlns:a14="http://schemas.microsoft.com/office/drawing/2010/main" Requires="a14">
+      <mc:AlternateContent xmlns:mc="http://schemas.openxmlformats.org/markup-compatibility/2006" xmlns:a14="http://schemas.microsoft.com/office/drawing/2010/main">
+        <mc:Choice Requires="a14">
           <p:sp>
             <p:nvSpPr>
               <p:cNvPr id="3" name="Content Placeholder 2"/>
@@ -9896,7 +9896,7 @@
                     <m:sSup>
                       <m:sSupPr>
                         <m:ctrlPr>
-                          <a:rPr lang="en-US">
+                          <a:rPr lang="en-US" i="1">
                             <a:solidFill>
                               <a:srgbClr val="000000"/>
                             </a:solidFill>
@@ -10012,7 +10012,7 @@
                     <m:sSubSup>
                       <m:sSubSupPr>
                         <m:ctrlPr>
-                          <a:rPr lang="en-US">
+                          <a:rPr lang="en-US" i="1">
                             <a:solidFill>
                               <a:srgbClr val="000000"/>
                             </a:solidFill>
@@ -10114,7 +10114,7 @@
                     <m:sSup>
                       <m:sSupPr>
                         <m:ctrlPr>
-                          <a:rPr lang="en-US">
+                          <a:rPr lang="en-US" i="1">
                             <a:solidFill>
                               <a:srgbClr val="000000"/>
                             </a:solidFill>
@@ -10199,7 +10199,7 @@
                     <m:sSubSup>
                       <m:sSubSupPr>
                         <m:ctrlPr>
-                          <a:rPr lang="en-US">
+                          <a:rPr lang="en-US" i="1">
                             <a:solidFill>
                               <a:srgbClr val="000000"/>
                             </a:solidFill>
@@ -10442,7 +10442,7 @@
                     <m:sSubSup>
                       <m:sSubSupPr>
                         <m:ctrlPr>
-                          <a:rPr lang="en-US">
+                          <a:rPr lang="en-US" i="1">
                             <a:solidFill>
                               <a:srgbClr val="000000"/>
                             </a:solidFill>
@@ -10559,7 +10559,7 @@
             </p:txBody>
           </p:sp>
         </mc:Choice>
-        <mc:Fallback>
+        <mc:Fallback xmlns="">
           <p:sp>
             <p:nvSpPr>
               <p:cNvPr id="3" name="Content Placeholder 2"/>
@@ -10667,8 +10667,8 @@
           </a:p>
         </p:txBody>
       </p:sp>
-      <mc:AlternateContent xmlns:mc="http://schemas.openxmlformats.org/markup-compatibility/2006">
-        <mc:Choice xmlns:a14="http://schemas.microsoft.com/office/drawing/2010/main" Requires="a14">
+      <mc:AlternateContent xmlns:mc="http://schemas.openxmlformats.org/markup-compatibility/2006" xmlns:a14="http://schemas.microsoft.com/office/drawing/2010/main">
+        <mc:Choice Requires="a14">
           <p:sp>
             <p:nvSpPr>
               <p:cNvPr id="3" name="Content Placeholder 2"/>
@@ -10775,7 +10775,7 @@
                     <m:sSub>
                       <m:sSubPr>
                         <m:ctrlPr>
-                          <a:rPr lang="en-US">
+                          <a:rPr lang="en-US" i="1">
                             <a:solidFill>
                               <a:srgbClr val="000000"/>
                             </a:solidFill>
@@ -10945,7 +10945,7 @@
                       <m:sSub>
                         <m:sSubPr>
                           <m:ctrlPr>
-                            <a:rPr lang="en-US">
+                            <a:rPr lang="en-US" i="1">
                               <a:solidFill>
                                 <a:srgbClr val="000000"/>
                               </a:solidFill>
@@ -11353,7 +11353,7 @@
                     <m:sSup>
                       <m:sSupPr>
                         <m:ctrlPr>
-                          <a:rPr lang="en-US">
+                          <a:rPr lang="en-US" i="1">
                             <a:solidFill>
                               <a:srgbClr val="000000"/>
                             </a:solidFill>
@@ -11533,7 +11533,7 @@
             </p:txBody>
           </p:sp>
         </mc:Choice>
-        <mc:Fallback>
+        <mc:Fallback xmlns="">
           <p:sp>
             <p:nvSpPr>
               <p:cNvPr id="3" name="Content Placeholder 2"/>
@@ -12573,8 +12573,8 @@
           </a:p>
         </p:txBody>
       </p:sp>
-      <mc:AlternateContent xmlns:mc="http://schemas.openxmlformats.org/markup-compatibility/2006">
-        <mc:Choice xmlns:a14="http://schemas.microsoft.com/office/drawing/2010/main" Requires="a14">
+      <mc:AlternateContent xmlns:mc="http://schemas.openxmlformats.org/markup-compatibility/2006" xmlns:a14="http://schemas.microsoft.com/office/drawing/2010/main">
+        <mc:Choice Requires="a14">
           <p:sp>
             <p:nvSpPr>
               <p:cNvPr id="3" name="Content Placeholder 2"/>
@@ -12618,7 +12618,7 @@
                     <m:sSup>
                       <m:sSupPr>
                         <m:ctrlPr>
-                          <a:rPr lang="en-US">
+                          <a:rPr lang="en-US" i="1">
                             <a:solidFill>
                               <a:srgbClr val="000000"/>
                             </a:solidFill>
@@ -12674,7 +12674,7 @@
                     <m:sSub>
                       <m:sSubPr>
                         <m:ctrlPr>
-                          <a:rPr lang="en-US">
+                          <a:rPr lang="en-US" i="1">
                             <a:solidFill>
                               <a:srgbClr val="000000"/>
                             </a:solidFill>
@@ -12914,7 +12914,7 @@
                     <m:sSub>
                       <m:sSubPr>
                         <m:ctrlPr>
-                          <a:rPr lang="en-US">
+                          <a:rPr lang="en-US" i="1">
                             <a:solidFill>
                               <a:srgbClr val="000000"/>
                             </a:solidFill>
@@ -12960,7 +12960,7 @@
                     <m:sSub>
                       <m:sSubPr>
                         <m:ctrlPr>
-                          <a:rPr lang="en-US">
+                          <a:rPr lang="en-US" i="1">
                             <a:solidFill>
                               <a:srgbClr val="000000"/>
                             </a:solidFill>
@@ -13005,7 +13005,7 @@
             </p:txBody>
           </p:sp>
         </mc:Choice>
-        <mc:Fallback>
+        <mc:Fallback xmlns="">
           <p:sp>
             <p:nvSpPr>
               <p:cNvPr id="3" name="Content Placeholder 2"/>
@@ -13143,8 +13143,8 @@
           </a:p>
         </p:txBody>
       </p:sp>
-      <mc:AlternateContent xmlns:mc="http://schemas.openxmlformats.org/markup-compatibility/2006">
-        <mc:Choice xmlns:a14="http://schemas.microsoft.com/office/drawing/2010/main" Requires="a14">
+      <mc:AlternateContent xmlns:mc="http://schemas.openxmlformats.org/markup-compatibility/2006" xmlns:a14="http://schemas.microsoft.com/office/drawing/2010/main">
+        <mc:Choice Requires="a14">
           <p:sp>
             <p:nvSpPr>
               <p:cNvPr id="3" name="Content Placeholder 2"/>
@@ -13188,7 +13188,7 @@
                     <m:sSub>
                       <m:sSubPr>
                         <m:ctrlPr>
-                          <a:rPr lang="en-US">
+                          <a:rPr lang="en-US" i="1">
                             <a:solidFill>
                               <a:srgbClr val="000000"/>
                             </a:solidFill>
@@ -13338,7 +13338,7 @@
                     <m:sSub>
                       <m:sSubPr>
                         <m:ctrlPr>
-                          <a:rPr lang="en-US">
+                          <a:rPr lang="en-US" i="1">
                             <a:solidFill>
                               <a:srgbClr val="000000"/>
                             </a:solidFill>
@@ -13555,7 +13555,7 @@
                       <m:sSubSup>
                         <m:sSubSupPr>
                           <m:ctrlPr>
-                            <a:rPr lang="en-US">
+                            <a:rPr lang="en-US" i="1">
                               <a:solidFill>
                                 <a:srgbClr val="000000"/>
                               </a:solidFill>
@@ -13858,7 +13858,7 @@
                       <m:sSubSup>
                         <m:sSubSupPr>
                           <m:ctrlPr>
-                            <a:rPr lang="en-US">
+                            <a:rPr lang="en-US" i="1">
                               <a:solidFill>
                                 <a:srgbClr val="000000"/>
                               </a:solidFill>
@@ -14197,7 +14197,7 @@
                     <m:sSup>
                       <m:sSupPr>
                         <m:ctrlPr>
-                          <a:rPr lang="en-US">
+                          <a:rPr lang="en-US" i="1">
                             <a:solidFill>
                               <a:srgbClr val="000000"/>
                             </a:solidFill>
@@ -14261,7 +14261,7 @@
                     <m:sSub>
                       <m:sSubPr>
                         <m:ctrlPr>
-                          <a:rPr lang="en-US">
+                          <a:rPr lang="en-US" i="1">
                             <a:solidFill>
                               <a:srgbClr val="000000"/>
                             </a:solidFill>
@@ -14317,7 +14317,7 @@
                     <m:sSub>
                       <m:sSubPr>
                         <m:ctrlPr>
-                          <a:rPr lang="en-US">
+                          <a:rPr lang="en-US" i="1">
                             <a:solidFill>
                               <a:srgbClr val="000000"/>
                             </a:solidFill>
@@ -14363,7 +14363,7 @@
                     <m:sSub>
                       <m:sSubPr>
                         <m:ctrlPr>
-                          <a:rPr lang="en-US">
+                          <a:rPr lang="en-US" i="1">
                             <a:solidFill>
                               <a:srgbClr val="000000"/>
                             </a:solidFill>
@@ -14493,7 +14493,7 @@
             </p:txBody>
           </p:sp>
         </mc:Choice>
-        <mc:Fallback>
+        <mc:Fallback xmlns="">
           <p:sp>
             <p:nvSpPr>
               <p:cNvPr id="3" name="Content Placeholder 2"/>
@@ -14637,8 +14637,8 @@
           </a:p>
         </p:txBody>
       </p:sp>
-      <mc:AlternateContent xmlns:mc="http://schemas.openxmlformats.org/markup-compatibility/2006">
-        <mc:Choice xmlns:a14="http://schemas.microsoft.com/office/drawing/2010/main" Requires="a14">
+      <mc:AlternateContent xmlns:mc="http://schemas.openxmlformats.org/markup-compatibility/2006" xmlns:a14="http://schemas.microsoft.com/office/drawing/2010/main">
+        <mc:Choice Requires="a14">
           <p:sp>
             <p:nvSpPr>
               <p:cNvPr id="3" name="Content Placeholder 2"/>
@@ -14745,7 +14745,7 @@
                     <m:sSup>
                       <m:sSupPr>
                         <m:ctrlPr>
-                          <a:rPr lang="en-US">
+                          <a:rPr lang="en-US" i="1">
                             <a:solidFill>
                               <a:srgbClr val="000000"/>
                             </a:solidFill>
@@ -14809,7 +14809,7 @@
             </p:txBody>
           </p:sp>
         </mc:Choice>
-        <mc:Fallback>
+        <mc:Fallback xmlns="">
           <p:sp>
             <p:nvSpPr>
               <p:cNvPr id="3" name="Content Placeholder 2"/>
@@ -15674,8 +15674,8 @@
           </a:p>
         </p:txBody>
       </p:sp>
-      <mc:AlternateContent xmlns:mc="http://schemas.openxmlformats.org/markup-compatibility/2006">
-        <mc:Choice xmlns:a14="http://schemas.microsoft.com/office/drawing/2010/main" Requires="a14">
+      <mc:AlternateContent xmlns:mc="http://schemas.openxmlformats.org/markup-compatibility/2006" xmlns:a14="http://schemas.microsoft.com/office/drawing/2010/main">
+        <mc:Choice Requires="a14">
           <p:sp>
             <p:nvSpPr>
               <p:cNvPr id="3" name="Content Placeholder 2"/>
@@ -15732,7 +15732,7 @@
                     <m:sSup>
                       <m:sSupPr>
                         <m:ctrlPr>
-                          <a:rPr lang="en-US">
+                          <a:rPr lang="en-US" i="1">
                             <a:solidFill>
                               <a:srgbClr val="000000"/>
                             </a:solidFill>
@@ -15818,7 +15818,7 @@
                     <m:sSub>
                       <m:sSubPr>
                         <m:ctrlPr>
-                          <a:rPr lang="en-US">
+                          <a:rPr lang="en-US" i="1">
                             <a:solidFill>
                               <a:srgbClr val="000000"/>
                             </a:solidFill>
@@ -15864,7 +15864,7 @@
                     <m:sSub>
                       <m:sSubPr>
                         <m:ctrlPr>
-                          <a:rPr lang="en-US">
+                          <a:rPr lang="en-US" i="1">
                             <a:solidFill>
                               <a:srgbClr val="000000"/>
                             </a:solidFill>
@@ -15910,7 +15910,7 @@
                     <m:sSup>
                       <m:sSupPr>
                         <m:ctrlPr>
-                          <a:rPr lang="en-US">
+                          <a:rPr lang="en-US" i="1">
                             <a:solidFill>
                               <a:srgbClr val="000000"/>
                             </a:solidFill>
@@ -16023,7 +16023,7 @@
             </p:txBody>
           </p:sp>
         </mc:Choice>
-        <mc:Fallback>
+        <mc:Fallback xmlns="">
           <p:sp>
             <p:nvSpPr>
               <p:cNvPr id="3" name="Content Placeholder 2"/>
@@ -16350,9 +16350,9 @@
           <a:lstStyle/>
           <a:p>
             <a:r>
-              <a:rPr dirty="0"/>
-              <a:t>Part 2 · 네 가지 해법을 하나의 표준으로</a:t>
+              <a:t>Part 2</a:t>
             </a:r>
+            <a:endParaRPr dirty="0"/>
           </a:p>
         </p:txBody>
       </p:sp>
@@ -16426,8 +16426,8 @@
           </a:p>
         </p:txBody>
       </p:sp>
-      <mc:AlternateContent xmlns:mc="http://schemas.openxmlformats.org/markup-compatibility/2006">
-        <mc:Choice xmlns:a14="http://schemas.microsoft.com/office/drawing/2010/main" Requires="a14">
+      <mc:AlternateContent xmlns:mc="http://schemas.openxmlformats.org/markup-compatibility/2006" xmlns:a14="http://schemas.microsoft.com/office/drawing/2010/main">
+        <mc:Choice Requires="a14">
           <p:sp>
             <p:nvSpPr>
               <p:cNvPr id="3" name="Content Placeholder 2"/>
@@ -16631,7 +16631,7 @@
             </p:txBody>
           </p:sp>
         </mc:Choice>
-        <mc:Fallback>
+        <mc:Fallback xmlns="">
           <p:sp>
             <p:nvSpPr>
               <p:cNvPr id="3" name="Content Placeholder 2"/>
@@ -17671,8 +17671,8 @@
           </a:p>
         </p:txBody>
       </p:sp>
-      <mc:AlternateContent xmlns:mc="http://schemas.openxmlformats.org/markup-compatibility/2006">
-        <mc:Choice xmlns:a14="http://schemas.microsoft.com/office/drawing/2010/main" Requires="a14">
+      <mc:AlternateContent xmlns:mc="http://schemas.openxmlformats.org/markup-compatibility/2006" xmlns:a14="http://schemas.microsoft.com/office/drawing/2010/main">
+        <mc:Choice Requires="a14">
           <p:sp>
             <p:nvSpPr>
               <p:cNvPr id="3" name="Content Placeholder 2"/>
@@ -17826,9 +17826,6 @@
                       <m:t>x</m:t>
                     </m:r>
                     <m:r>
-                      <m:rPr>
-                        <m:sty m:val="p"/>
-                      </m:rPr>
                       <a:rPr lang="en-US" i="0">
                         <a:solidFill>
                           <a:srgbClr val="000000"/>
@@ -17871,9 +17868,6 @@
                       <m:t>x</m:t>
                     </m:r>
                     <m:r>
-                      <m:rPr>
-                        <m:sty m:val="p"/>
-                      </m:rPr>
                       <a:rPr lang="en-US" i="0">
                         <a:solidFill>
                           <a:srgbClr val="000000"/>
@@ -17916,9 +17910,6 @@
                       <m:t>x</m:t>
                     </m:r>
                     <m:r>
-                      <m:rPr>
-                        <m:sty m:val="p"/>
-                      </m:rPr>
                       <a:rPr lang="en-US" i="0">
                         <a:solidFill>
                           <a:srgbClr val="000000"/>
@@ -17976,9 +17967,6 @@
                       <m:t>x</m:t>
                     </m:r>
                     <m:r>
-                      <m:rPr>
-                        <m:sty m:val="p"/>
-                      </m:rPr>
                       <a:rPr lang="en-US" i="0">
                         <a:solidFill>
                           <a:srgbClr val="000000"/>
@@ -18018,19 +18006,7 @@
                         </a:solidFill>
                         <a:latin typeface="Cambria Math"/>
                       </a:rPr>
-                      <m:t>x</m:t>
-                    </m:r>
-                    <m:r>
-                      <m:rPr>
-                        <m:sty m:val="p"/>
-                      </m:rPr>
-                      <a:rPr lang="en-US" i="0">
-                        <a:solidFill>
-                          <a:srgbClr val="000000"/>
-                        </a:solidFill>
-                        <a:latin typeface="Cambria Math"/>
-                      </a:rPr>
-                      <m:t>FF</m:t>
+                      <m:t>xFF</m:t>
                     </m:r>
                   </m:oMath>
                 </a14:m>
@@ -18105,7 +18081,7 @@
             </p:txBody>
           </p:sp>
         </mc:Choice>
-        <mc:Fallback>
+        <mc:Fallback xmlns="">
           <p:sp>
             <p:nvSpPr>
               <p:cNvPr id="3" name="Content Placeholder 2"/>
@@ -18428,8 +18404,8 @@
           </a:p>
         </p:txBody>
       </p:sp>
-      <mc:AlternateContent xmlns:mc="http://schemas.openxmlformats.org/markup-compatibility/2006">
-        <mc:Choice xmlns:a14="http://schemas.microsoft.com/office/drawing/2010/main" Requires="a14">
+      <mc:AlternateContent xmlns:mc="http://schemas.openxmlformats.org/markup-compatibility/2006" xmlns:a14="http://schemas.microsoft.com/office/drawing/2010/main">
+        <mc:Choice Requires="a14">
           <p:sp>
             <p:nvSpPr>
               <p:cNvPr id="3" name="Content Placeholder 2"/>
@@ -18465,7 +18441,7 @@
                     <m:sSub>
                       <m:sSubPr>
                         <m:ctrlPr>
-                          <a:rPr lang="en-US">
+                          <a:rPr lang="en-US" i="1">
                             <a:solidFill>
                               <a:srgbClr val="000000"/>
                             </a:solidFill>
@@ -18532,7 +18508,7 @@
                     <m:sSup>
                       <m:sSupPr>
                         <m:ctrlPr>
-                          <a:rPr lang="en-US">
+                          <a:rPr lang="en-US" i="1">
                             <a:solidFill>
                               <a:srgbClr val="000000"/>
                             </a:solidFill>
@@ -18602,7 +18578,7 @@
                     <m:sSub>
                       <m:sSubPr>
                         <m:ctrlPr>
-                          <a:rPr lang="en-US">
+                          <a:rPr lang="en-US" i="1">
                             <a:solidFill>
                               <a:srgbClr val="000000"/>
                             </a:solidFill>
@@ -18904,7 +18880,7 @@
                     <m:sSub>
                       <m:sSubPr>
                         <m:ctrlPr>
-                          <a:rPr lang="en-US">
+                          <a:rPr lang="en-US" i="1">
                             <a:solidFill>
                               <a:srgbClr val="000000"/>
                             </a:solidFill>
@@ -19097,7 +19073,7 @@
                     <m:sSub>
                       <m:sSubPr>
                         <m:ctrlPr>
-                          <a:rPr lang="en-US">
+                          <a:rPr lang="en-US" i="1">
                             <a:solidFill>
                               <a:srgbClr val="000000"/>
                             </a:solidFill>
@@ -19143,7 +19119,7 @@
                     <m:sSub>
                       <m:sSubPr>
                         <m:ctrlPr>
-                          <a:rPr lang="en-US">
+                          <a:rPr lang="en-US" i="1">
                             <a:solidFill>
                               <a:srgbClr val="000000"/>
                             </a:solidFill>
@@ -19189,7 +19165,7 @@
                     <m:sSub>
                       <m:sSubPr>
                         <m:ctrlPr>
-                          <a:rPr lang="en-US">
+                          <a:rPr lang="en-US" i="1">
                             <a:solidFill>
                               <a:srgbClr val="000000"/>
                             </a:solidFill>
@@ -19245,7 +19221,7 @@
                     <m:sSubSup>
                       <m:sSubSupPr>
                         <m:ctrlPr>
-                          <a:rPr lang="en-US">
+                          <a:rPr lang="en-US" i="1">
                             <a:solidFill>
                               <a:srgbClr val="000000"/>
                             </a:solidFill>
@@ -19302,7 +19278,7 @@
                     <m:sSup>
                       <m:sSupPr>
                         <m:ctrlPr>
-                          <a:rPr lang="en-US">
+                          <a:rPr lang="en-US" i="1">
                             <a:solidFill>
                               <a:srgbClr val="000000"/>
                             </a:solidFill>
@@ -19357,7 +19333,7 @@
                       <m:sSup>
                         <m:sSupPr>
                           <m:ctrlPr>
-                            <a:rPr lang="en-US">
+                            <a:rPr lang="en-US" i="1">
                               <a:solidFill>
                                 <a:srgbClr val="000000"/>
                               </a:solidFill>
@@ -19443,7 +19419,7 @@
             </p:txBody>
           </p:sp>
         </mc:Choice>
-        <mc:Fallback>
+        <mc:Fallback xmlns="">
           <p:sp>
             <p:nvSpPr>
               <p:cNvPr id="3" name="Content Placeholder 2"/>
@@ -19632,8 +19608,8 @@
           </a:p>
         </p:txBody>
       </p:sp>
-      <mc:AlternateContent xmlns:mc="http://schemas.openxmlformats.org/markup-compatibility/2006">
-        <mc:Choice xmlns:a14="http://schemas.microsoft.com/office/drawing/2010/main" Requires="a14">
+      <mc:AlternateContent xmlns:mc="http://schemas.openxmlformats.org/markup-compatibility/2006" xmlns:a14="http://schemas.microsoft.com/office/drawing/2010/main">
+        <mc:Choice Requires="a14">
           <p:sp>
             <p:nvSpPr>
               <p:cNvPr id="3" name="Content Placeholder 2"/>
@@ -19688,7 +19664,7 @@
                     <m:sSup>
                       <m:sSupPr>
                         <m:ctrlPr>
-                          <a:rPr lang="en-US">
+                          <a:rPr lang="en-US" i="1">
                             <a:solidFill>
                               <a:srgbClr val="000000"/>
                             </a:solidFill>
@@ -19734,7 +19710,7 @@
                     <m:sSub>
                       <m:sSubPr>
                         <m:ctrlPr>
-                          <a:rPr lang="en-US">
+                          <a:rPr lang="en-US" i="1">
                             <a:solidFill>
                               <a:srgbClr val="000000"/>
                             </a:solidFill>
@@ -19885,7 +19861,7 @@
                     <m:sSup>
                       <m:sSupPr>
                         <m:ctrlPr>
-                          <a:rPr lang="en-US">
+                          <a:rPr lang="en-US" i="1">
                             <a:solidFill>
                               <a:srgbClr val="000000"/>
                             </a:solidFill>
@@ -20010,7 +19986,7 @@
                     <m:sSub>
                       <m:sSubPr>
                         <m:ctrlPr>
-                          <a:rPr lang="en-US">
+                          <a:rPr lang="en-US" i="1">
                             <a:solidFill>
                               <a:srgbClr val="000000"/>
                             </a:solidFill>
@@ -20241,7 +20217,7 @@
                     <m:sSub>
                       <m:sSubPr>
                         <m:ctrlPr>
-                          <a:rPr lang="en-US">
+                          <a:rPr lang="en-US" i="1">
                             <a:solidFill>
                               <a:srgbClr val="000000"/>
                             </a:solidFill>
@@ -20491,7 +20467,7 @@
                     <m:sSub>
                       <m:sSubPr>
                         <m:ctrlPr>
-                          <a:rPr lang="en-US">
+                          <a:rPr lang="en-US" i="1">
                             <a:solidFill>
                               <a:srgbClr val="000000"/>
                             </a:solidFill>
@@ -20545,7 +20521,7 @@
                     <m:sSub>
                       <m:sSubPr>
                         <m:ctrlPr>
-                          <a:rPr lang="en-US">
+                          <a:rPr lang="en-US" i="1">
                             <a:solidFill>
                               <a:srgbClr val="000000"/>
                             </a:solidFill>
@@ -20707,7 +20683,7 @@
             </p:txBody>
           </p:sp>
         </mc:Choice>
-        <mc:Fallback>
+        <mc:Fallback xmlns="">
           <p:sp>
             <p:nvSpPr>
               <p:cNvPr id="3" name="Content Placeholder 2"/>
@@ -20862,8 +20838,8 @@
           </a:p>
         </p:txBody>
       </p:sp>
-      <mc:AlternateContent xmlns:mc="http://schemas.openxmlformats.org/markup-compatibility/2006">
-        <mc:Choice xmlns:a14="http://schemas.microsoft.com/office/drawing/2010/main" Requires="a14">
+      <mc:AlternateContent xmlns:mc="http://schemas.openxmlformats.org/markup-compatibility/2006" xmlns:a14="http://schemas.microsoft.com/office/drawing/2010/main">
+        <mc:Choice Requires="a14">
           <p:sp>
             <p:nvSpPr>
               <p:cNvPr id="3" name="Content Placeholder 2"/>
@@ -21015,7 +20991,7 @@
             </p:txBody>
           </p:sp>
         </mc:Choice>
-        <mc:Fallback>
+        <mc:Fallback xmlns="">
           <p:sp>
             <p:nvSpPr>
               <p:cNvPr id="3" name="Content Placeholder 2"/>
@@ -25818,8 +25794,8 @@
           </a:p>
         </p:txBody>
       </p:sp>
-      <mc:AlternateContent xmlns:mc="http://schemas.openxmlformats.org/markup-compatibility/2006">
-        <mc:Choice xmlns:a14="http://schemas.microsoft.com/office/drawing/2010/main" Requires="a14">
+      <mc:AlternateContent xmlns:mc="http://schemas.openxmlformats.org/markup-compatibility/2006" xmlns:a14="http://schemas.microsoft.com/office/drawing/2010/main">
+        <mc:Choice Requires="a14">
           <p:sp>
             <p:nvSpPr>
               <p:cNvPr id="3" name="Content Placeholder 2"/>
@@ -26241,7 +26217,7 @@
             </p:txBody>
           </p:sp>
         </mc:Choice>
-        <mc:Fallback>
+        <mc:Fallback xmlns="">
           <p:sp>
             <p:nvSpPr>
               <p:cNvPr id="3" name="Content Placeholder 2"/>
@@ -26379,8 +26355,8 @@
           </a:p>
         </p:txBody>
       </p:sp>
-      <mc:AlternateContent xmlns:mc="http://schemas.openxmlformats.org/markup-compatibility/2006">
-        <mc:Choice xmlns:a14="http://schemas.microsoft.com/office/drawing/2010/main" Requires="a14">
+      <mc:AlternateContent xmlns:mc="http://schemas.openxmlformats.org/markup-compatibility/2006" xmlns:a14="http://schemas.microsoft.com/office/drawing/2010/main">
+        <mc:Choice Requires="a14">
           <p:sp>
             <p:nvSpPr>
               <p:cNvPr id="3" name="Content Placeholder 2"/>
@@ -26435,7 +26411,7 @@
                     <m:sSup>
                       <m:sSupPr>
                         <m:ctrlPr>
-                          <a:rPr lang="en-US">
+                          <a:rPr lang="en-US" i="1">
                             <a:solidFill>
                               <a:srgbClr val="000000"/>
                             </a:solidFill>
@@ -26518,7 +26494,7 @@
                     <m:sSub>
                       <m:sSubPr>
                         <m:ctrlPr>
-                          <a:rPr lang="en-US">
+                          <a:rPr lang="en-US" i="1">
                             <a:solidFill>
                               <a:srgbClr val="000000"/>
                             </a:solidFill>
@@ -26559,9 +26535,16 @@
                   </a:rPr>
                   <a:t>로 쪼갠다 (블록 수 </a:t>
                 </a:r>
-                <a14:m xmlns:m="http://schemas.openxmlformats.org/officeDocument/2006/math">
-                  <m:oMath xmlns:mml="http://www.w3.org/1998/Math/MathML">
+                <a14:m>
+                  <m:oMath xmlns:m="http://schemas.openxmlformats.org/officeDocument/2006/math">
                     <m:sSub>
+                      <m:sSubPr>
+                        <m:ctrlPr>
+                          <a:rPr lang="en-US">
+                            <a:latin typeface="Cambria Math" panose="02040503050406030204" pitchFamily="18" charset="0"/>
+                          </a:rPr>
+                        </m:ctrlPr>
+                      </m:sSubPr>
                       <m:e>
                         <m:r>
                           <a:rPr lang="en-US" i="1">
@@ -26583,7 +26566,25 @@
                       <a:rPr lang="en-US" i="1">
                         <a:latin typeface="Cambria Math"/>
                       </a:rPr>
-                      <m:t>=n/w</m:t>
+                      <m:t>=</m:t>
+                    </m:r>
+                    <m:r>
+                      <a:rPr lang="en-US" i="1">
+                        <a:latin typeface="Cambria Math"/>
+                      </a:rPr>
+                      <m:t>𝑛</m:t>
+                    </m:r>
+                    <m:r>
+                      <a:rPr lang="en-US" i="1">
+                        <a:latin typeface="Cambria Math"/>
+                      </a:rPr>
+                      <m:t>/</m:t>
+                    </m:r>
+                    <m:r>
+                      <a:rPr lang="en-US" i="1">
+                        <a:latin typeface="Cambria Math"/>
+                      </a:rPr>
+                      <m:t>𝑤</m:t>
                     </m:r>
                   </m:oMath>
                 </a14:m>
@@ -26610,7 +26611,7 @@
                     <m:sSub>
                       <m:sSubPr>
                         <m:ctrlPr>
-                          <a:rPr lang="en-US">
+                          <a:rPr lang="en-US" i="1">
                             <a:solidFill>
                               <a:srgbClr val="000000"/>
                             </a:solidFill>
@@ -26785,7 +26786,7 @@
                     <m:sSub>
                       <m:sSubPr>
                         <m:ctrlPr>
-                          <a:rPr lang="en-US">
+                          <a:rPr lang="en-US" i="1">
                             <a:solidFill>
                               <a:srgbClr val="000000"/>
                             </a:solidFill>
@@ -26831,7 +26832,7 @@
                     <m:sSub>
                       <m:sSubPr>
                         <m:ctrlPr>
-                          <a:rPr lang="en-US">
+                          <a:rPr lang="en-US" i="1">
                             <a:solidFill>
                               <a:srgbClr val="000000"/>
                             </a:solidFill>
@@ -26884,7 +26885,7 @@
                     <m:sSub>
                       <m:sSubPr>
                         <m:ctrlPr>
-                          <a:rPr lang="en-US">
+                          <a:rPr lang="en-US" i="1">
                             <a:solidFill>
                               <a:srgbClr val="000000"/>
                             </a:solidFill>
@@ -27050,7 +27051,7 @@
                     <m:sSub>
                       <m:sSubPr>
                         <m:ctrlPr>
-                          <a:rPr lang="en-US">
+                          <a:rPr lang="en-US" i="1">
                             <a:solidFill>
                               <a:srgbClr val="000000"/>
                             </a:solidFill>
@@ -27106,7 +27107,7 @@
                     <m:sSup>
                       <m:sSupPr>
                         <m:ctrlPr>
-                          <a:rPr lang="en-US">
+                          <a:rPr lang="en-US" i="1">
                             <a:solidFill>
                               <a:srgbClr val="000000"/>
                             </a:solidFill>
@@ -27349,7 +27350,7 @@
             </p:txBody>
           </p:sp>
         </mc:Choice>
-        <mc:Fallback>
+        <mc:Fallback xmlns="">
           <p:sp>
             <p:nvSpPr>
               <p:cNvPr id="3" name="Content Placeholder 2"/>
@@ -27457,8 +27458,8 @@
           </a:p>
         </p:txBody>
       </p:sp>
-      <mc:AlternateContent xmlns:mc="http://schemas.openxmlformats.org/markup-compatibility/2006">
-        <mc:Choice xmlns:a14="http://schemas.microsoft.com/office/drawing/2010/main" Requires="a14">
+      <mc:AlternateContent xmlns:mc="http://schemas.openxmlformats.org/markup-compatibility/2006" xmlns:a14="http://schemas.microsoft.com/office/drawing/2010/main">
+        <mc:Choice Requires="a14">
           <p:sp>
             <p:nvSpPr>
               <p:cNvPr id="3" name="Content Placeholder 2"/>
@@ -27542,7 +27543,7 @@
                     <m:sSup>
                       <m:sSupPr>
                         <m:ctrlPr>
-                          <a:rPr lang="en-US">
+                          <a:rPr lang="en-US" i="1">
                             <a:solidFill>
                               <a:srgbClr val="000000"/>
                             </a:solidFill>
@@ -27606,7 +27607,7 @@
             </p:txBody>
           </p:sp>
         </mc:Choice>
-        <mc:Fallback>
+        <mc:Fallback xmlns="">
           <p:sp>
             <p:nvSpPr>
               <p:cNvPr id="3" name="Content Placeholder 2"/>
@@ -27714,8 +27715,8 @@
           </a:p>
         </p:txBody>
       </p:sp>
-      <mc:AlternateContent xmlns:mc="http://schemas.openxmlformats.org/markup-compatibility/2006">
-        <mc:Choice xmlns:a14="http://schemas.microsoft.com/office/drawing/2010/main" Requires="a14">
+      <mc:AlternateContent xmlns:mc="http://schemas.openxmlformats.org/markup-compatibility/2006" xmlns:a14="http://schemas.microsoft.com/office/drawing/2010/main">
+        <mc:Choice Requires="a14">
           <p:sp>
             <p:nvSpPr>
               <p:cNvPr id="3" name="Content Placeholder 2"/>
@@ -28310,7 +28311,7 @@
             </p:txBody>
           </p:sp>
         </mc:Choice>
-        <mc:Fallback>
+        <mc:Fallback xmlns="">
           <p:sp>
             <p:nvSpPr>
               <p:cNvPr id="3" name="Content Placeholder 2"/>

</xml_diff>